<commit_message>
⬆️ ASIR: Subida de nuevos materiales y prácticas
</commit_message>
<xml_diff>
--- a/2ASIR/sostenibilidad/practica/Tarea1_ODS_presentacion.pptx
+++ b/2ASIR/sostenibilidad/practica/Tarea1_ODS_presentacion.pptx
@@ -3540,87 +3540,6 @@
           </a:ln>
         </p:spPr>
       </p:sp>
-      <p:sp>
-        <p:nvSpPr>
-          <p:cNvPr id="3" name="Fondo imagen ODS 1"/>
-          <p:cNvSpPr/>
-          <p:nvPr/>
-        </p:nvSpPr>
-        <p:spPr>
-          <a:xfrm>
-            <a:off x="4572000" y="411480"/>
-            <a:ext cx="7223760" cy="2468880"/>
-          </a:xfrm>
-          <a:prstGeom prst="rect">
-            <a:avLst/>
-          </a:prstGeom>
-          <a:solidFill>
-            <a:srgbClr val="E4E8F0"/>
-          </a:solidFill>
-          <a:ln w="12700">
-            <a:solidFill>
-              <a:srgbClr val="E4E8F0"/>
-            </a:solidFill>
-            <a:prstDash val="solid"/>
-          </a:ln>
-        </p:spPr>
-      </p:sp>
-      <p:sp>
-        <p:nvSpPr>
-          <p:cNvPr id="4" name="Text 2"/>
-          <p:cNvSpPr txBox="1"/>
-          <p:nvPr/>
-        </p:nvSpPr>
-        <p:spPr>
-          <a:xfrm>
-            <a:off x="4572000" y="2148840"/>
-            <a:ext cx="7223760" cy="640080"/>
-          </a:xfrm>
-          <a:prstGeom prst="rect">
-            <a:avLst/>
-          </a:prstGeom>
-          <a:noFill/>
-          <a:ln/>
-        </p:spPr>
-        <p:txBody>
-          <a:bodyPr wrap="square" lIns="0" tIns="0" rIns="0" bIns="0" rtlCol="0" anchor="ctr"/>
-          <a:lstStyle/>
-          <a:p>
-            <a:pPr marL="0" indent="0" algn="ctr">
-              <a:buNone/>
-            </a:pPr>
-            <a:r>
-              <a:rPr lang="en-US" sz="2000" b="1" dirty="0">
-                <a:solidFill>
-                  <a:srgbClr val="6B7488"/>
-                </a:solidFill>
-                <a:latin typeface="Calibri" pitchFamily="34" charset="0"/>
-                <a:ea typeface="Calibri" pitchFamily="34" charset="-122"/>
-                <a:cs typeface="Calibri" pitchFamily="34" charset="-120"/>
-              </a:rPr>
-              <a:t>Tu imagen del ODS 1</a:t>
-            </a:r>
-            <a:endParaRPr lang="en-US" sz="2000" dirty="0"/>
-          </a:p>
-          <a:p>
-            <a:pPr marL="0" indent="0" algn="ctr">
-              <a:buNone/>
-            </a:pPr>
-            <a:r>
-              <a:rPr lang="en-US" sz="1300" dirty="0">
-                <a:solidFill>
-                  <a:srgbClr val="6B7488"/>
-                </a:solidFill>
-                <a:latin typeface="Calibri" pitchFamily="34" charset="0"/>
-                <a:ea typeface="Calibri" pitchFamily="34" charset="-122"/>
-                <a:cs typeface="Calibri" pitchFamily="34" charset="-120"/>
-              </a:rPr>
-              <a:t>Haz clic en el icono del centro para insertarla</a:t>
-            </a:r>
-            <a:endParaRPr lang="en-US" sz="2000" dirty="0"/>
-          </a:p>
-        </p:txBody>
-      </p:sp>
       <p:pic>
         <p:nvPicPr>
           <p:cNvPr id="5" name="Image 0" descr="Icono ODS 1"/>
@@ -4107,43 +4026,6 @@
       </p:sp>
       <p:sp>
         <p:nvSpPr>
-          <p:cNvPr id="19" name="Text 0"/>
-          <p:cNvSpPr>
-            <a:spLocks noGrp="1"/>
-          </p:cNvSpPr>
-          <p:nvPr>
-            <p:ph idx="100" hasCustomPrompt="1"/>
-          </p:nvPr>
-        </p:nvSpPr>
-        <p:spPr>
-          <a:xfrm>
-            <a:off x="4572000" y="411480"/>
-            <a:ext cx="7223760" cy="2468880"/>
-          </a:xfrm>
-          <a:prstGeom prst="rect">
-            <a:avLst/>
-          </a:prstGeom>
-          <a:noFill/>
-          <a:ln w="19050">
-            <a:solidFill>
-              <a:srgbClr val="8A93A6"/>
-            </a:solidFill>
-            <a:prstDash val="dash"/>
-          </a:ln>
-        </p:spPr>
-        <p:txBody>
-          <a:bodyPr wrap="square" rtlCol="0"/>
-          <a:lstStyle/>
-          <a:p>
-            <a:pPr marL="0" indent="0">
-              <a:buNone/>
-            </a:pPr>
-            <a:endParaRPr lang="en-US" dirty="0"/>
-          </a:p>
-        </p:txBody>
-      </p:sp>
-      <p:sp>
-        <p:nvSpPr>
           <p:cNvPr id="25" name="Slide Number Placeholder 0"/>
           <p:cNvSpPr>
             <a:spLocks noGrp="1"/>
@@ -4192,32 +4074,32 @@
       </p:sp>
       <p:pic>
         <p:nvPicPr>
-          <p:cNvPr id="23" name="Marcador de posición de imagen 22">
+          <p:cNvPr id="33" name="Imagen 32">
             <a:extLst>
               <a:ext uri="{FF2B5EF4-FFF2-40B4-BE49-F238E27FC236}">
-                <a16:creationId xmlns:a16="http://schemas.microsoft.com/office/drawing/2014/main" id="{AD425C44-9C16-870B-33E1-6DBBB2FB2610}"/>
+                <a16:creationId xmlns:a16="http://schemas.microsoft.com/office/drawing/2014/main" id="{F97602C1-AF1A-DC10-862B-53294C2D7BE3}"/>
               </a:ext>
             </a:extLst>
           </p:cNvPr>
           <p:cNvPicPr>
-            <a:picLocks noGrp="1" noChangeAspect="1"/>
+            <a:picLocks noChangeAspect="1"/>
           </p:cNvPicPr>
-          <p:nvPr>
-            <p:ph type="pic" idx="100"/>
-          </p:nvPr>
+          <p:nvPr/>
         </p:nvPicPr>
         <p:blipFill>
           <a:blip r:embed="rId5"/>
-          <a:srcRect t="17090" b="634"/>
           <a:stretch>
             <a:fillRect/>
           </a:stretch>
         </p:blipFill>
         <p:spPr>
           <a:xfrm>
-            <a:off x="4572000" y="77724"/>
-            <a:ext cx="7223760" cy="2971800"/>
-          </a:xfrm>
+            <a:off x="4572000" y="109728"/>
+            <a:ext cx="7223760" cy="2880360"/>
+          </a:xfrm>
+          <a:prstGeom prst="rect">
+            <a:avLst/>
+          </a:prstGeom>
         </p:spPr>
       </p:pic>
     </p:spTree>
@@ -4270,87 +4152,6 @@
           </a:ln>
         </p:spPr>
       </p:sp>
-      <p:sp>
-        <p:nvSpPr>
-          <p:cNvPr id="3" name="Fondo imagen ODS 2"/>
-          <p:cNvSpPr/>
-          <p:nvPr/>
-        </p:nvSpPr>
-        <p:spPr>
-          <a:xfrm>
-            <a:off x="4572000" y="411480"/>
-            <a:ext cx="7223760" cy="2468880"/>
-          </a:xfrm>
-          <a:prstGeom prst="rect">
-            <a:avLst/>
-          </a:prstGeom>
-          <a:solidFill>
-            <a:srgbClr val="E4E8F0"/>
-          </a:solidFill>
-          <a:ln w="12700">
-            <a:solidFill>
-              <a:srgbClr val="E4E8F0"/>
-            </a:solidFill>
-            <a:prstDash val="solid"/>
-          </a:ln>
-        </p:spPr>
-      </p:sp>
-      <p:sp>
-        <p:nvSpPr>
-          <p:cNvPr id="4" name="Text 2"/>
-          <p:cNvSpPr txBox="1"/>
-          <p:nvPr/>
-        </p:nvSpPr>
-        <p:spPr>
-          <a:xfrm>
-            <a:off x="4572000" y="2148840"/>
-            <a:ext cx="7223760" cy="640080"/>
-          </a:xfrm>
-          <a:prstGeom prst="rect">
-            <a:avLst/>
-          </a:prstGeom>
-          <a:noFill/>
-          <a:ln/>
-        </p:spPr>
-        <p:txBody>
-          <a:bodyPr wrap="square" lIns="0" tIns="0" rIns="0" bIns="0" rtlCol="0" anchor="ctr"/>
-          <a:lstStyle/>
-          <a:p>
-            <a:pPr marL="0" indent="0" algn="ctr">
-              <a:buNone/>
-            </a:pPr>
-            <a:r>
-              <a:rPr lang="en-US" sz="2000" b="1" dirty="0">
-                <a:solidFill>
-                  <a:srgbClr val="6B7488"/>
-                </a:solidFill>
-                <a:latin typeface="Calibri" pitchFamily="34" charset="0"/>
-                <a:ea typeface="Calibri" pitchFamily="34" charset="-122"/>
-                <a:cs typeface="Calibri" pitchFamily="34" charset="-120"/>
-              </a:rPr>
-              <a:t>Tu imagen del ODS 2</a:t>
-            </a:r>
-            <a:endParaRPr lang="en-US" sz="2000" dirty="0"/>
-          </a:p>
-          <a:p>
-            <a:pPr marL="0" indent="0" algn="ctr">
-              <a:buNone/>
-            </a:pPr>
-            <a:r>
-              <a:rPr lang="en-US" sz="1300" dirty="0">
-                <a:solidFill>
-                  <a:srgbClr val="6B7488"/>
-                </a:solidFill>
-                <a:latin typeface="Calibri" pitchFamily="34" charset="0"/>
-                <a:ea typeface="Calibri" pitchFamily="34" charset="-122"/>
-                <a:cs typeface="Calibri" pitchFamily="34" charset="-120"/>
-              </a:rPr>
-              <a:t>Haz clic en el icono del centro para insertarla</a:t>
-            </a:r>
-            <a:endParaRPr lang="en-US" sz="2000" dirty="0"/>
-          </a:p>
-        </p:txBody>
-      </p:sp>
       <p:pic>
         <p:nvPicPr>
           <p:cNvPr id="5" name="Image 0" descr="Icono ODS 2"/>
@@ -4914,43 +4715,6 @@
       </p:sp>
       <p:sp>
         <p:nvSpPr>
-          <p:cNvPr id="21" name="Text 0"/>
-          <p:cNvSpPr>
-            <a:spLocks noGrp="1"/>
-          </p:cNvSpPr>
-          <p:nvPr>
-            <p:ph idx="100" hasCustomPrompt="1"/>
-          </p:nvPr>
-        </p:nvSpPr>
-        <p:spPr>
-          <a:xfrm>
-            <a:off x="4572000" y="411480"/>
-            <a:ext cx="7223760" cy="2468880"/>
-          </a:xfrm>
-          <a:prstGeom prst="rect">
-            <a:avLst/>
-          </a:prstGeom>
-          <a:noFill/>
-          <a:ln w="19050">
-            <a:solidFill>
-              <a:srgbClr val="8A93A6"/>
-            </a:solidFill>
-            <a:prstDash val="dash"/>
-          </a:ln>
-        </p:spPr>
-        <p:txBody>
-          <a:bodyPr wrap="square" rtlCol="0"/>
-          <a:lstStyle/>
-          <a:p>
-            <a:pPr marL="0" indent="0">
-              <a:buNone/>
-            </a:pPr>
-            <a:endParaRPr lang="en-US" dirty="0"/>
-          </a:p>
-        </p:txBody>
-      </p:sp>
-      <p:sp>
-        <p:nvSpPr>
           <p:cNvPr id="25" name="Slide Number Placeholder 0"/>
           <p:cNvSpPr>
             <a:spLocks noGrp="1"/>
@@ -4999,32 +4763,32 @@
       </p:sp>
       <p:pic>
         <p:nvPicPr>
-          <p:cNvPr id="23" name="Marcador de posición de imagen 22">
+          <p:cNvPr id="31" name="Imagen 30">
             <a:extLst>
               <a:ext uri="{FF2B5EF4-FFF2-40B4-BE49-F238E27FC236}">
-                <a16:creationId xmlns:a16="http://schemas.microsoft.com/office/drawing/2014/main" id="{D65A4A5F-FB81-C816-7651-E04ECFC457C2}"/>
+                <a16:creationId xmlns:a16="http://schemas.microsoft.com/office/drawing/2014/main" id="{8E96850D-E027-378D-53D5-9F2C88D03A61}"/>
               </a:ext>
             </a:extLst>
           </p:cNvPr>
           <p:cNvPicPr>
-            <a:picLocks noGrp="1" noChangeAspect="1"/>
+            <a:picLocks noChangeAspect="1"/>
           </p:cNvPicPr>
-          <p:nvPr>
-            <p:ph type="pic" idx="100"/>
-          </p:nvPr>
+          <p:nvPr/>
         </p:nvPicPr>
         <p:blipFill>
           <a:blip r:embed="rId5"/>
-          <a:srcRect t="6502" b="40746"/>
           <a:stretch>
             <a:fillRect/>
           </a:stretch>
         </p:blipFill>
         <p:spPr>
           <a:xfrm>
-            <a:off x="4572000" y="109727"/>
-            <a:ext cx="7223760" cy="2867025"/>
-          </a:xfrm>
+            <a:off x="4572000" y="109728"/>
+            <a:ext cx="7223760" cy="2907792"/>
+          </a:xfrm>
+          <a:prstGeom prst="rect">
+            <a:avLst/>
+          </a:prstGeom>
         </p:spPr>
       </p:pic>
     </p:spTree>
@@ -5077,87 +4841,6 @@
           </a:ln>
         </p:spPr>
       </p:sp>
-      <p:sp>
-        <p:nvSpPr>
-          <p:cNvPr id="3" name="Fondo imagen ODS 3"/>
-          <p:cNvSpPr/>
-          <p:nvPr/>
-        </p:nvSpPr>
-        <p:spPr>
-          <a:xfrm>
-            <a:off x="4572000" y="411480"/>
-            <a:ext cx="7223760" cy="2468880"/>
-          </a:xfrm>
-          <a:prstGeom prst="rect">
-            <a:avLst/>
-          </a:prstGeom>
-          <a:solidFill>
-            <a:srgbClr val="E4E8F0"/>
-          </a:solidFill>
-          <a:ln w="12700">
-            <a:solidFill>
-              <a:srgbClr val="E4E8F0"/>
-            </a:solidFill>
-            <a:prstDash val="solid"/>
-          </a:ln>
-        </p:spPr>
-      </p:sp>
-      <p:sp>
-        <p:nvSpPr>
-          <p:cNvPr id="4" name="Text 2"/>
-          <p:cNvSpPr txBox="1"/>
-          <p:nvPr/>
-        </p:nvSpPr>
-        <p:spPr>
-          <a:xfrm>
-            <a:off x="4572000" y="2148840"/>
-            <a:ext cx="7223760" cy="640080"/>
-          </a:xfrm>
-          <a:prstGeom prst="rect">
-            <a:avLst/>
-          </a:prstGeom>
-          <a:noFill/>
-          <a:ln/>
-        </p:spPr>
-        <p:txBody>
-          <a:bodyPr wrap="square" lIns="0" tIns="0" rIns="0" bIns="0" rtlCol="0" anchor="ctr"/>
-          <a:lstStyle/>
-          <a:p>
-            <a:pPr marL="0" indent="0" algn="ctr">
-              <a:buNone/>
-            </a:pPr>
-            <a:r>
-              <a:rPr lang="en-US" sz="2000" b="1" dirty="0">
-                <a:solidFill>
-                  <a:srgbClr val="6B7488"/>
-                </a:solidFill>
-                <a:latin typeface="Calibri" pitchFamily="34" charset="0"/>
-                <a:ea typeface="Calibri" pitchFamily="34" charset="-122"/>
-                <a:cs typeface="Calibri" pitchFamily="34" charset="-120"/>
-              </a:rPr>
-              <a:t>Tu imagen del ODS 3</a:t>
-            </a:r>
-            <a:endParaRPr lang="en-US" sz="2000" dirty="0"/>
-          </a:p>
-          <a:p>
-            <a:pPr marL="0" indent="0" algn="ctr">
-              <a:buNone/>
-            </a:pPr>
-            <a:r>
-              <a:rPr lang="en-US" sz="1300" dirty="0">
-                <a:solidFill>
-                  <a:srgbClr val="6B7488"/>
-                </a:solidFill>
-                <a:latin typeface="Calibri" pitchFamily="34" charset="0"/>
-                <a:ea typeface="Calibri" pitchFamily="34" charset="-122"/>
-                <a:cs typeface="Calibri" pitchFamily="34" charset="-120"/>
-              </a:rPr>
-              <a:t>Haz clic en el icono del centro para insertarla</a:t>
-            </a:r>
-            <a:endParaRPr lang="en-US" sz="2000" dirty="0"/>
-          </a:p>
-        </p:txBody>
-      </p:sp>
       <p:pic>
         <p:nvPicPr>
           <p:cNvPr id="5" name="Image 0" descr="Icono ODS 3"/>
@@ -5394,7 +5077,7 @@
         </p:nvSpPr>
         <p:spPr>
           <a:xfrm>
-            <a:off x="4572000" y="3108960"/>
+            <a:off x="4572000" y="3225586"/>
             <a:ext cx="3520440" cy="3246120"/>
           </a:xfrm>
           <a:prstGeom prst="rect">
@@ -5419,7 +5102,7 @@
         </p:nvSpPr>
         <p:spPr>
           <a:xfrm>
-            <a:off x="4572000" y="3108960"/>
+            <a:off x="4572000" y="3225586"/>
             <a:ext cx="3520440" cy="82296"/>
           </a:xfrm>
           <a:prstGeom prst="rect">
@@ -5444,7 +5127,7 @@
         </p:nvSpPr>
         <p:spPr>
           <a:xfrm>
-            <a:off x="4754880" y="3310128"/>
+            <a:off x="4754880" y="3426754"/>
             <a:ext cx="3154680" cy="365760"/>
           </a:xfrm>
           <a:prstGeom prst="rect">
@@ -5483,7 +5166,7 @@
         </p:nvSpPr>
         <p:spPr>
           <a:xfrm>
-            <a:off x="4754880" y="3749040"/>
+            <a:off x="4754880" y="3865666"/>
             <a:ext cx="3154680" cy="2514600"/>
           </a:xfrm>
           <a:prstGeom prst="rect">
@@ -5522,7 +5205,7 @@
         </p:nvSpPr>
         <p:spPr>
           <a:xfrm>
-            <a:off x="8275320" y="3108960"/>
+            <a:off x="8275320" y="3225586"/>
             <a:ext cx="3520440" cy="3246120"/>
           </a:xfrm>
           <a:prstGeom prst="rect">
@@ -5547,7 +5230,7 @@
         </p:nvSpPr>
         <p:spPr>
           <a:xfrm>
-            <a:off x="8275320" y="3108960"/>
+            <a:off x="8275320" y="3225586"/>
             <a:ext cx="3520440" cy="82296"/>
           </a:xfrm>
           <a:prstGeom prst="rect">
@@ -5572,7 +5255,7 @@
         </p:nvSpPr>
         <p:spPr>
           <a:xfrm>
-            <a:off x="8458200" y="3310128"/>
+            <a:off x="8458200" y="3426754"/>
             <a:ext cx="3154680" cy="365760"/>
           </a:xfrm>
           <a:prstGeom prst="rect">
@@ -5611,7 +5294,7 @@
         </p:nvSpPr>
         <p:spPr>
           <a:xfrm>
-            <a:off x="8458200" y="3749040"/>
+            <a:off x="8458200" y="3865666"/>
             <a:ext cx="3154680" cy="2514600"/>
           </a:xfrm>
           <a:prstGeom prst="rect">
@@ -5639,43 +5322,6 @@
               <a:t>Los ataques, los bombardeos y los desplazamientos de población dañaron hospitales y otras infraestructuras sanitarias en Ucrania, dificultando el acceso a tratamientos y medicamentos. Además, millones de personas tuvieron que abandonar sus hogares, lo que incrementó sus necesidades de atención médica y psicológica. La guerra también desvió recursos públicos hacia la defensa y la atención de emergencias, limitando las posibilidades de inversión en otros servicios sanitarios.</a:t>
             </a:r>
             <a:endParaRPr lang="en-US" sz="1250" dirty="0"/>
-          </a:p>
-        </p:txBody>
-      </p:sp>
-      <p:sp>
-        <p:nvSpPr>
-          <p:cNvPr id="19" name="Text 0"/>
-          <p:cNvSpPr>
-            <a:spLocks noGrp="1"/>
-          </p:cNvSpPr>
-          <p:nvPr>
-            <p:ph idx="100" hasCustomPrompt="1"/>
-          </p:nvPr>
-        </p:nvSpPr>
-        <p:spPr>
-          <a:xfrm>
-            <a:off x="4572000" y="411480"/>
-            <a:ext cx="7223760" cy="2468880"/>
-          </a:xfrm>
-          <a:prstGeom prst="rect">
-            <a:avLst/>
-          </a:prstGeom>
-          <a:noFill/>
-          <a:ln w="19050">
-            <a:solidFill>
-              <a:srgbClr val="8A93A6"/>
-            </a:solidFill>
-            <a:prstDash val="dash"/>
-          </a:ln>
-        </p:spPr>
-        <p:txBody>
-          <a:bodyPr wrap="square" rtlCol="0"/>
-          <a:lstStyle/>
-          <a:p>
-            <a:pPr marL="0" indent="0">
-              <a:buNone/>
-            </a:pPr>
-            <a:endParaRPr lang="en-US" dirty="0"/>
           </a:p>
         </p:txBody>
       </p:sp>
@@ -5729,32 +5375,32 @@
       </p:sp>
       <p:pic>
         <p:nvPicPr>
-          <p:cNvPr id="21" name="Marcador de posición de imagen 20">
+          <p:cNvPr id="33" name="Imagen 32">
             <a:extLst>
               <a:ext uri="{FF2B5EF4-FFF2-40B4-BE49-F238E27FC236}">
-                <a16:creationId xmlns:a16="http://schemas.microsoft.com/office/drawing/2014/main" id="{A2E24B6D-64DD-0DDD-4692-20196C0BD00A}"/>
+                <a16:creationId xmlns:a16="http://schemas.microsoft.com/office/drawing/2014/main" id="{8A0064EB-5AD6-031F-5CF6-36C68A19EB6C}"/>
               </a:ext>
             </a:extLst>
           </p:cNvPr>
           <p:cNvPicPr>
-            <a:picLocks noGrp="1" noChangeAspect="1"/>
+            <a:picLocks noChangeAspect="1"/>
           </p:cNvPicPr>
-          <p:nvPr>
-            <p:ph type="pic" idx="100"/>
-          </p:nvPr>
+          <p:nvPr/>
         </p:nvPicPr>
         <p:blipFill>
           <a:blip r:embed="rId5"/>
-          <a:srcRect t="5562" b="2534"/>
           <a:stretch>
             <a:fillRect/>
           </a:stretch>
         </p:blipFill>
         <p:spPr>
           <a:xfrm>
-            <a:off x="4572000" y="184785"/>
-            <a:ext cx="7223760" cy="2832735"/>
-          </a:xfrm>
+            <a:off x="4572000" y="109729"/>
+            <a:ext cx="7223760" cy="2996986"/>
+          </a:xfrm>
+          <a:prstGeom prst="rect">
+            <a:avLst/>
+          </a:prstGeom>
         </p:spPr>
       </p:pic>
     </p:spTree>
@@ -5807,87 +5453,6 @@
           </a:ln>
         </p:spPr>
       </p:sp>
-      <p:sp>
-        <p:nvSpPr>
-          <p:cNvPr id="3" name="Fondo imagen ODS 7"/>
-          <p:cNvSpPr/>
-          <p:nvPr/>
-        </p:nvSpPr>
-        <p:spPr>
-          <a:xfrm>
-            <a:off x="4572000" y="411480"/>
-            <a:ext cx="7223760" cy="2468880"/>
-          </a:xfrm>
-          <a:prstGeom prst="rect">
-            <a:avLst/>
-          </a:prstGeom>
-          <a:solidFill>
-            <a:srgbClr val="E4E8F0"/>
-          </a:solidFill>
-          <a:ln w="12700">
-            <a:solidFill>
-              <a:srgbClr val="E4E8F0"/>
-            </a:solidFill>
-            <a:prstDash val="solid"/>
-          </a:ln>
-        </p:spPr>
-      </p:sp>
-      <p:sp>
-        <p:nvSpPr>
-          <p:cNvPr id="4" name="Text 2"/>
-          <p:cNvSpPr txBox="1"/>
-          <p:nvPr/>
-        </p:nvSpPr>
-        <p:spPr>
-          <a:xfrm>
-            <a:off x="4572000" y="2148840"/>
-            <a:ext cx="7223760" cy="640080"/>
-          </a:xfrm>
-          <a:prstGeom prst="rect">
-            <a:avLst/>
-          </a:prstGeom>
-          <a:noFill/>
-          <a:ln/>
-        </p:spPr>
-        <p:txBody>
-          <a:bodyPr wrap="square" lIns="0" tIns="0" rIns="0" bIns="0" rtlCol="0" anchor="ctr"/>
-          <a:lstStyle/>
-          <a:p>
-            <a:pPr marL="0" indent="0" algn="ctr">
-              <a:buNone/>
-            </a:pPr>
-            <a:r>
-              <a:rPr lang="en-US" sz="2000" b="1" dirty="0">
-                <a:solidFill>
-                  <a:srgbClr val="6B7488"/>
-                </a:solidFill>
-                <a:latin typeface="Calibri" pitchFamily="34" charset="0"/>
-                <a:ea typeface="Calibri" pitchFamily="34" charset="-122"/>
-                <a:cs typeface="Calibri" pitchFamily="34" charset="-120"/>
-              </a:rPr>
-              <a:t>Tu imagen del ODS 7</a:t>
-            </a:r>
-            <a:endParaRPr lang="en-US" sz="2000" dirty="0"/>
-          </a:p>
-          <a:p>
-            <a:pPr marL="0" indent="0" algn="ctr">
-              <a:buNone/>
-            </a:pPr>
-            <a:r>
-              <a:rPr lang="en-US" sz="1300" dirty="0">
-                <a:solidFill>
-                  <a:srgbClr val="6B7488"/>
-                </a:solidFill>
-                <a:latin typeface="Calibri" pitchFamily="34" charset="0"/>
-                <a:ea typeface="Calibri" pitchFamily="34" charset="-122"/>
-                <a:cs typeface="Calibri" pitchFamily="34" charset="-120"/>
-              </a:rPr>
-              <a:t>Haz clic en el icono del centro para insertarla</a:t>
-            </a:r>
-            <a:endParaRPr lang="en-US" sz="2000" dirty="0"/>
-          </a:p>
-        </p:txBody>
-      </p:sp>
       <p:pic>
         <p:nvPicPr>
           <p:cNvPr id="5" name="Image 0" descr="Icono ODS 7"/>
@@ -6124,7 +5689,7 @@
         </p:nvSpPr>
         <p:spPr>
           <a:xfrm>
-            <a:off x="4572000" y="3108960"/>
+            <a:off x="4572000" y="3227832"/>
             <a:ext cx="3520440" cy="3246120"/>
           </a:xfrm>
           <a:prstGeom prst="rect">
@@ -6149,7 +5714,7 @@
         </p:nvSpPr>
         <p:spPr>
           <a:xfrm>
-            <a:off x="4572000" y="3108960"/>
+            <a:off x="4572000" y="3227832"/>
             <a:ext cx="3520440" cy="82296"/>
           </a:xfrm>
           <a:prstGeom prst="rect">
@@ -6174,7 +5739,7 @@
         </p:nvSpPr>
         <p:spPr>
           <a:xfrm>
-            <a:off x="4754880" y="3310128"/>
+            <a:off x="4754880" y="3429000"/>
             <a:ext cx="3154680" cy="365760"/>
           </a:xfrm>
           <a:prstGeom prst="rect">
@@ -6213,7 +5778,7 @@
         </p:nvSpPr>
         <p:spPr>
           <a:xfrm>
-            <a:off x="4754880" y="3749040"/>
+            <a:off x="4754880" y="3867912"/>
             <a:ext cx="3154680" cy="2514600"/>
           </a:xfrm>
           <a:prstGeom prst="rect">
@@ -6252,7 +5817,7 @@
         </p:nvSpPr>
         <p:spPr>
           <a:xfrm>
-            <a:off x="8275320" y="3108960"/>
+            <a:off x="8275320" y="3227832"/>
             <a:ext cx="3520440" cy="3246120"/>
           </a:xfrm>
           <a:prstGeom prst="rect">
@@ -6277,7 +5842,7 @@
         </p:nvSpPr>
         <p:spPr>
           <a:xfrm>
-            <a:off x="8275320" y="3108960"/>
+            <a:off x="8275320" y="3227832"/>
             <a:ext cx="3520440" cy="82296"/>
           </a:xfrm>
           <a:prstGeom prst="rect">
@@ -6302,7 +5867,7 @@
         </p:nvSpPr>
         <p:spPr>
           <a:xfrm>
-            <a:off x="8458200" y="3310128"/>
+            <a:off x="8458200" y="3429000"/>
             <a:ext cx="3154680" cy="365760"/>
           </a:xfrm>
           <a:prstGeom prst="rect">
@@ -6341,7 +5906,7 @@
         </p:nvSpPr>
         <p:spPr>
           <a:xfrm>
-            <a:off x="8458200" y="3749040"/>
+            <a:off x="8458200" y="3867912"/>
             <a:ext cx="3154680" cy="2514600"/>
           </a:xfrm>
           <a:prstGeom prst="rect">
@@ -6369,43 +5934,6 @@
               <a:t>Las sanciones económicas, las restricciones comerciales y las alteraciones del suministro energético ruso provocaron importantes subidas y fluctuaciones de los precios del gas, el petróleo y la electricidad. En Europa, esto aumentó las facturas de hogares y empresas y agravó la pobreza energética. Al mismo tiempo, la crisis impulsó a varios países a buscar proveedores alternativos y acelerar sus inversiones en energías renovables, aunque también aumentó temporalmente el uso de algunos combustibles fósiles.</a:t>
             </a:r>
             <a:endParaRPr lang="en-US" sz="1250" dirty="0"/>
-          </a:p>
-        </p:txBody>
-      </p:sp>
-      <p:sp>
-        <p:nvSpPr>
-          <p:cNvPr id="19" name="Text 0"/>
-          <p:cNvSpPr>
-            <a:spLocks noGrp="1"/>
-          </p:cNvSpPr>
-          <p:nvPr>
-            <p:ph idx="100" hasCustomPrompt="1"/>
-          </p:nvPr>
-        </p:nvSpPr>
-        <p:spPr>
-          <a:xfrm>
-            <a:off x="4572000" y="411480"/>
-            <a:ext cx="7223760" cy="2468880"/>
-          </a:xfrm>
-          <a:prstGeom prst="rect">
-            <a:avLst/>
-          </a:prstGeom>
-          <a:noFill/>
-          <a:ln w="19050">
-            <a:solidFill>
-              <a:srgbClr val="8A93A6"/>
-            </a:solidFill>
-            <a:prstDash val="dash"/>
-          </a:ln>
-        </p:spPr>
-        <p:txBody>
-          <a:bodyPr wrap="square" rtlCol="0"/>
-          <a:lstStyle/>
-          <a:p>
-            <a:pPr marL="0" indent="0">
-              <a:buNone/>
-            </a:pPr>
-            <a:endParaRPr lang="en-US" dirty="0"/>
           </a:p>
         </p:txBody>
       </p:sp>
@@ -6459,28 +5987,33 @@
       </p:sp>
       <p:pic>
         <p:nvPicPr>
-          <p:cNvPr id="21" name="Marcador de posición de imagen 20">
+          <p:cNvPr id="27" name="Imagen 26">
             <a:extLst>
               <a:ext uri="{FF2B5EF4-FFF2-40B4-BE49-F238E27FC236}">
-                <a16:creationId xmlns:a16="http://schemas.microsoft.com/office/drawing/2014/main" id="{14ED86C5-5DE2-A18E-690B-CE1CA553A25D}"/>
+                <a16:creationId xmlns:a16="http://schemas.microsoft.com/office/drawing/2014/main" id="{A510B21F-DEBE-A198-5B7B-86699E2893B5}"/>
               </a:ext>
             </a:extLst>
           </p:cNvPr>
           <p:cNvPicPr>
-            <a:picLocks noGrp="1" noChangeAspect="1"/>
+            <a:picLocks noChangeAspect="1"/>
           </p:cNvPicPr>
-          <p:nvPr>
-            <p:ph type="pic" idx="100"/>
-          </p:nvPr>
+          <p:nvPr/>
         </p:nvPicPr>
         <p:blipFill>
           <a:blip r:embed="rId5"/>
-          <a:srcRect t="8380" b="8380"/>
           <a:stretch>
             <a:fillRect/>
           </a:stretch>
         </p:blipFill>
-        <p:spPr/>
+        <p:spPr>
+          <a:xfrm>
+            <a:off x="4572000" y="109728"/>
+            <a:ext cx="7223760" cy="2999232"/>
+          </a:xfrm>
+          <a:prstGeom prst="rect">
+            <a:avLst/>
+          </a:prstGeom>
+        </p:spPr>
       </p:pic>
     </p:spTree>
   </p:cSld>
@@ -6532,87 +6065,6 @@
           </a:ln>
         </p:spPr>
       </p:sp>
-      <p:sp>
-        <p:nvSpPr>
-          <p:cNvPr id="3" name="Fondo imagen ODS 8"/>
-          <p:cNvSpPr/>
-          <p:nvPr/>
-        </p:nvSpPr>
-        <p:spPr>
-          <a:xfrm>
-            <a:off x="4572000" y="411480"/>
-            <a:ext cx="7223760" cy="2468880"/>
-          </a:xfrm>
-          <a:prstGeom prst="rect">
-            <a:avLst/>
-          </a:prstGeom>
-          <a:solidFill>
-            <a:srgbClr val="E4E8F0"/>
-          </a:solidFill>
-          <a:ln w="12700">
-            <a:solidFill>
-              <a:srgbClr val="E4E8F0"/>
-            </a:solidFill>
-            <a:prstDash val="solid"/>
-          </a:ln>
-        </p:spPr>
-      </p:sp>
-      <p:sp>
-        <p:nvSpPr>
-          <p:cNvPr id="4" name="Text 2"/>
-          <p:cNvSpPr txBox="1"/>
-          <p:nvPr/>
-        </p:nvSpPr>
-        <p:spPr>
-          <a:xfrm>
-            <a:off x="4572000" y="2148840"/>
-            <a:ext cx="7223760" cy="640080"/>
-          </a:xfrm>
-          <a:prstGeom prst="rect">
-            <a:avLst/>
-          </a:prstGeom>
-          <a:noFill/>
-          <a:ln/>
-        </p:spPr>
-        <p:txBody>
-          <a:bodyPr wrap="square" lIns="0" tIns="0" rIns="0" bIns="0" rtlCol="0" anchor="ctr"/>
-          <a:lstStyle/>
-          <a:p>
-            <a:pPr marL="0" indent="0" algn="ctr">
-              <a:buNone/>
-            </a:pPr>
-            <a:r>
-              <a:rPr lang="en-US" sz="2000" b="1" dirty="0">
-                <a:solidFill>
-                  <a:srgbClr val="6B7488"/>
-                </a:solidFill>
-                <a:latin typeface="Calibri" pitchFamily="34" charset="0"/>
-                <a:ea typeface="Calibri" pitchFamily="34" charset="-122"/>
-                <a:cs typeface="Calibri" pitchFamily="34" charset="-120"/>
-              </a:rPr>
-              <a:t>Tu imagen del ODS 8</a:t>
-            </a:r>
-            <a:endParaRPr lang="en-US" sz="2000" dirty="0"/>
-          </a:p>
-          <a:p>
-            <a:pPr marL="0" indent="0" algn="ctr">
-              <a:buNone/>
-            </a:pPr>
-            <a:r>
-              <a:rPr lang="en-US" sz="1300" dirty="0">
-                <a:solidFill>
-                  <a:srgbClr val="6B7488"/>
-                </a:solidFill>
-                <a:latin typeface="Calibri" pitchFamily="34" charset="0"/>
-                <a:ea typeface="Calibri" pitchFamily="34" charset="-122"/>
-                <a:cs typeface="Calibri" pitchFamily="34" charset="-120"/>
-              </a:rPr>
-              <a:t>Haz clic en el icono del centro para insertarla</a:t>
-            </a:r>
-            <a:endParaRPr lang="en-US" sz="2000" dirty="0"/>
-          </a:p>
-        </p:txBody>
-      </p:sp>
       <p:pic>
         <p:nvPicPr>
           <p:cNvPr id="5" name="Image 0" descr="Icono ODS 8"/>
@@ -7099,43 +6551,6 @@
       </p:sp>
       <p:sp>
         <p:nvSpPr>
-          <p:cNvPr id="19" name="Text 0"/>
-          <p:cNvSpPr>
-            <a:spLocks noGrp="1"/>
-          </p:cNvSpPr>
-          <p:nvPr>
-            <p:ph idx="100" hasCustomPrompt="1"/>
-          </p:nvPr>
-        </p:nvSpPr>
-        <p:spPr>
-          <a:xfrm>
-            <a:off x="4572000" y="411480"/>
-            <a:ext cx="7223760" cy="2468880"/>
-          </a:xfrm>
-          <a:prstGeom prst="rect">
-            <a:avLst/>
-          </a:prstGeom>
-          <a:noFill/>
-          <a:ln w="19050">
-            <a:solidFill>
-              <a:srgbClr val="8A93A6"/>
-            </a:solidFill>
-            <a:prstDash val="dash"/>
-          </a:ln>
-        </p:spPr>
-        <p:txBody>
-          <a:bodyPr wrap="square" rtlCol="0"/>
-          <a:lstStyle/>
-          <a:p>
-            <a:pPr marL="0" indent="0">
-              <a:buNone/>
-            </a:pPr>
-            <a:endParaRPr lang="en-US" dirty="0"/>
-          </a:p>
-        </p:txBody>
-      </p:sp>
-      <p:sp>
-        <p:nvSpPr>
           <p:cNvPr id="25" name="Slide Number Placeholder 0"/>
           <p:cNvSpPr>
             <a:spLocks noGrp="1"/>
@@ -7182,25 +6597,36 @@
           </a:p>
         </p:txBody>
       </p:sp>
-      <p:sp>
-        <p:nvSpPr>
-          <p:cNvPr id="900" name="Marcador de imagen"/>
-          <p:cNvSpPr>
-            <a:spLocks noGrp="1"/>
-          </p:cNvSpPr>
-          <p:nvPr>
-            <p:ph type="pic" idx="100"/>
-          </p:nvPr>
-        </p:nvSpPr>
-        <p:spPr/>
-        <p:txBody>
-          <a:bodyPr/>
-          <a:lstStyle/>
-          <a:p>
-            <a:endParaRPr lang="es-ES"/>
-          </a:p>
-        </p:txBody>
-      </p:sp>
+      <p:pic>
+        <p:nvPicPr>
+          <p:cNvPr id="24" name="Imagen 23">
+            <a:extLst>
+              <a:ext uri="{FF2B5EF4-FFF2-40B4-BE49-F238E27FC236}">
+                <a16:creationId xmlns:a16="http://schemas.microsoft.com/office/drawing/2014/main" id="{4D5DF7E4-ABDE-8F17-62E6-F12FCFEF4A0A}"/>
+              </a:ext>
+            </a:extLst>
+          </p:cNvPr>
+          <p:cNvPicPr>
+            <a:picLocks noChangeAspect="1"/>
+          </p:cNvPicPr>
+          <p:nvPr/>
+        </p:nvPicPr>
+        <p:blipFill>
+          <a:blip r:embed="rId5"/>
+          <a:stretch>
+            <a:fillRect/>
+          </a:stretch>
+        </p:blipFill>
+        <p:spPr>
+          <a:xfrm>
+            <a:off x="4572000" y="109728"/>
+            <a:ext cx="7223760" cy="2880360"/>
+          </a:xfrm>
+          <a:prstGeom prst="rect">
+            <a:avLst/>
+          </a:prstGeom>
+        </p:spPr>
+      </p:pic>
     </p:spTree>
   </p:cSld>
   <p:clrMapOvr>

</xml_diff>